<commit_message>
Lecture 8: republish both decks with the concept-quiz answer slides removed
Philip re-exported the English and Korean Valuation Primer decks after deleting
the concept quiz that carried its solutions. English is 32 -> 31 slides, Korean
33 -> 32; no Answers: or 정답 text remains in either.

Only the two .pptx changed. PowerPoint had re-stamped cp:lastModifiedBy on both
files during the re-save, so they went through strip_metadata.ps1 again before
syncing - .pptx has no per-file equivalent of Word's removePersonalInformation
flag, so this is needed after every PowerPoint save.
</commit_message>
<xml_diff>
--- a/files/week2/english/Wk2_L8_slides.pptx
+++ b/files/week2/english/Wk2_L8_slides.pptx
@@ -5,7 +5,7 @@
     <p:sldMasterId id="2147483689" r:id="rId1"/>
   </p:sldMasterIdLst>
   <p:notesMasterIdLst>
-    <p:notesMasterId r:id="rId34"/>
+    <p:notesMasterId r:id="rId33"/>
   </p:notesMasterIdLst>
   <p:sldIdLst>
     <p:sldId id="256" r:id="rId2"/>
@@ -31,15 +31,14 @@
     <p:sldId id="273" r:id="rId22"/>
     <p:sldId id="274" r:id="rId23"/>
     <p:sldId id="275" r:id="rId24"/>
-    <p:sldId id="276" r:id="rId25"/>
-    <p:sldId id="544" r:id="rId26"/>
-    <p:sldId id="501" r:id="rId27"/>
-    <p:sldId id="507" r:id="rId28"/>
-    <p:sldId id="509" r:id="rId29"/>
-    <p:sldId id="542" r:id="rId30"/>
-    <p:sldId id="543" r:id="rId31"/>
-    <p:sldId id="546" r:id="rId32"/>
-    <p:sldId id="547" r:id="rId33"/>
+    <p:sldId id="544" r:id="rId25"/>
+    <p:sldId id="501" r:id="rId26"/>
+    <p:sldId id="507" r:id="rId27"/>
+    <p:sldId id="509" r:id="rId28"/>
+    <p:sldId id="542" r:id="rId29"/>
+    <p:sldId id="543" r:id="rId30"/>
+    <p:sldId id="546" r:id="rId31"/>
+    <p:sldId id="547" r:id="rId32"/>
   </p:sldIdLst>
   <p:sldSz cx="12192000" cy="6858000"/>
   <p:notesSz cx="6858000" cy="9144000"/>
@@ -170,7 +169,6 @@
             <p14:sldId id="273"/>
             <p14:sldId id="274"/>
             <p14:sldId id="275"/>
-            <p14:sldId id="276"/>
             <p14:sldId id="544"/>
             <p14:sldId id="501"/>
             <p14:sldId id="507"/>
@@ -1734,90 +1732,6 @@
   <p:cSld>
     <p:spTree>
       <p:nvGrpSpPr>
-        <p:cNvPr id="1" name=""/>
-        <p:cNvGrpSpPr/>
-        <p:nvPr/>
-      </p:nvGrpSpPr>
-      <p:grpSpPr>
-        <a:xfrm>
-          <a:off x="0" y="0"/>
-          <a:ext cx="0" cy="0"/>
-          <a:chOff x="0" y="0"/>
-          <a:chExt cx="0" cy="0"/>
-        </a:xfrm>
-      </p:grpSpPr>
-      <p:sp>
-        <p:nvSpPr>
-          <p:cNvPr id="2" name="Slide Image Placeholder 1"/>
-          <p:cNvSpPr>
-            <a:spLocks noGrp="1" noRot="1" noChangeAspect="1"/>
-          </p:cNvSpPr>
-          <p:nvPr>
-            <p:ph type="sldImg"/>
-          </p:nvPr>
-        </p:nvSpPr>
-        <p:spPr/>
-      </p:sp>
-      <p:sp>
-        <p:nvSpPr>
-          <p:cNvPr id="3" name="Notes Placeholder 2"/>
-          <p:cNvSpPr>
-            <a:spLocks noGrp="1"/>
-          </p:cNvSpPr>
-          <p:nvPr>
-            <p:ph type="body" idx="1"/>
-          </p:nvPr>
-        </p:nvSpPr>
-        <p:spPr/>
-        <p:txBody>
-          <a:bodyPr/>
-          <a:lstStyle/>
-          <a:p>
-            <a:endParaRPr lang="en-US" dirty="0"/>
-          </a:p>
-        </p:txBody>
-      </p:sp>
-      <p:sp>
-        <p:nvSpPr>
-          <p:cNvPr id="4" name="Slide Number Placeholder 3"/>
-          <p:cNvSpPr>
-            <a:spLocks noGrp="1"/>
-          </p:cNvSpPr>
-          <p:nvPr>
-            <p:ph type="sldNum" sz="quarter" idx="10"/>
-          </p:nvPr>
-        </p:nvSpPr>
-        <p:spPr/>
-        <p:txBody>
-          <a:bodyPr/>
-          <a:lstStyle/>
-          <a:p>
-            <a:fld id="{F7021451-1387-4CA6-816F-3879F97B5CBC}" type="slidenum">
-              <a:rPr lang="en-US"/>
-              <a:t>24</a:t>
-            </a:fld>
-            <a:endParaRPr lang="en-US"/>
-          </a:p>
-        </p:txBody>
-      </p:sp>
-    </p:spTree>
-    <p:extLst>
-      <p:ext uri="{BB962C8B-B14F-4D97-AF65-F5344CB8AC3E}">
-        <p14:creationId xmlns:p14="http://schemas.microsoft.com/office/powerpoint/2010/main" val="1024086991"/>
-      </p:ext>
-    </p:extLst>
-  </p:cSld>
-  <p:clrMapOvr>
-    <a:masterClrMapping/>
-  </p:clrMapOvr>
-</p:notes>
-</file>
-
-<file path=ppt/notesSlides/notesSlide21.xml><?xml version="1.0" encoding="utf-8"?>
-<p:notes xmlns:a="http://schemas.openxmlformats.org/drawingml/2006/main" xmlns:r="http://schemas.openxmlformats.org/officeDocument/2006/relationships" xmlns:p="http://schemas.openxmlformats.org/presentationml/2006/main">
-  <p:cSld>
-    <p:spTree>
-      <p:nvGrpSpPr>
         <p:cNvPr id="1" name="">
           <a:extLst>
             <a:ext uri="{FF2B5EF4-FFF2-40B4-BE49-F238E27FC236}">
@@ -1902,7 +1816,7 @@
           <a:p>
             <a:fld id="{D0E3E56B-C3C4-8E4F-B314-D5C81CC34EEF}" type="slidenum">
               <a:rPr lang="en-US" smtClean="0"/>
-              <a:t>26</a:t>
+              <a:t>25</a:t>
             </a:fld>
             <a:endParaRPr lang="en-US"/>
           </a:p>
@@ -1921,7 +1835,7 @@
 </p:notes>
 </file>
 
-<file path=ppt/notesSlides/notesSlide22.xml><?xml version="1.0" encoding="utf-8"?>
+<file path=ppt/notesSlides/notesSlide21.xml><?xml version="1.0" encoding="utf-8"?>
 <p:notes xmlns:a="http://schemas.openxmlformats.org/drawingml/2006/main" xmlns:r="http://schemas.openxmlformats.org/officeDocument/2006/relationships" xmlns:p="http://schemas.openxmlformats.org/presentationml/2006/main">
   <p:cSld>
     <p:spTree>
@@ -2010,7 +1924,7 @@
           <a:p>
             <a:fld id="{D0E3E56B-C3C4-8E4F-B314-D5C81CC34EEF}" type="slidenum">
               <a:rPr lang="en-US" smtClean="0"/>
-              <a:t>27</a:t>
+              <a:t>26</a:t>
             </a:fld>
             <a:endParaRPr lang="en-US"/>
           </a:p>
@@ -2029,7 +1943,7 @@
 </p:notes>
 </file>
 
-<file path=ppt/notesSlides/notesSlide23.xml><?xml version="1.0" encoding="utf-8"?>
+<file path=ppt/notesSlides/notesSlide22.xml><?xml version="1.0" encoding="utf-8"?>
 <p:notes xmlns:a="http://schemas.openxmlformats.org/drawingml/2006/main" xmlns:r="http://schemas.openxmlformats.org/officeDocument/2006/relationships" xmlns:p="http://schemas.openxmlformats.org/presentationml/2006/main">
   <p:cSld>
     <p:spTree>
@@ -2118,7 +2032,7 @@
           <a:p>
             <a:fld id="{D0E3E56B-C3C4-8E4F-B314-D5C81CC34EEF}" type="slidenum">
               <a:rPr lang="en-US" smtClean="0"/>
-              <a:t>28</a:t>
+              <a:t>27</a:t>
             </a:fld>
             <a:endParaRPr lang="en-US"/>
           </a:p>
@@ -2137,7 +2051,7 @@
 </p:notes>
 </file>
 
-<file path=ppt/notesSlides/notesSlide24.xml><?xml version="1.0" encoding="utf-8"?>
+<file path=ppt/notesSlides/notesSlide23.xml><?xml version="1.0" encoding="utf-8"?>
 <p:notes xmlns:a="http://schemas.openxmlformats.org/drawingml/2006/main" xmlns:r="http://schemas.openxmlformats.org/officeDocument/2006/relationships" xmlns:p="http://schemas.openxmlformats.org/presentationml/2006/main">
   <p:cSld>
     <p:spTree>
@@ -2226,7 +2140,7 @@
           <a:p>
             <a:fld id="{D0E3E56B-C3C4-8E4F-B314-D5C81CC34EEF}" type="slidenum">
               <a:rPr lang="en-US" smtClean="0"/>
-              <a:t>29</a:t>
+              <a:t>28</a:t>
             </a:fld>
             <a:endParaRPr lang="en-US"/>
           </a:p>
@@ -2245,7 +2159,7 @@
 </p:notes>
 </file>
 
-<file path=ppt/notesSlides/notesSlide25.xml><?xml version="1.0" encoding="utf-8"?>
+<file path=ppt/notesSlides/notesSlide24.xml><?xml version="1.0" encoding="utf-8"?>
 <p:notes xmlns:a="http://schemas.openxmlformats.org/drawingml/2006/main" xmlns:r="http://schemas.openxmlformats.org/officeDocument/2006/relationships" xmlns:p="http://schemas.openxmlformats.org/presentationml/2006/main">
   <p:cSld>
     <p:spTree>
@@ -2334,7 +2248,7 @@
           <a:p>
             <a:fld id="{D0E3E56B-C3C4-8E4F-B314-D5C81CC34EEF}" type="slidenum">
               <a:rPr lang="en-US" smtClean="0"/>
-              <a:t>30</a:t>
+              <a:t>29</a:t>
             </a:fld>
             <a:endParaRPr lang="en-US"/>
           </a:p>
@@ -2353,7 +2267,7 @@
 </p:notes>
 </file>
 
-<file path=ppt/notesSlides/notesSlide26.xml><?xml version="1.0" encoding="utf-8"?>
+<file path=ppt/notesSlides/notesSlide25.xml><?xml version="1.0" encoding="utf-8"?>
 <p:notes xmlns:a="http://schemas.openxmlformats.org/drawingml/2006/main" xmlns:r="http://schemas.openxmlformats.org/officeDocument/2006/relationships" xmlns:p="http://schemas.openxmlformats.org/presentationml/2006/main">
   <p:cSld>
     <p:spTree>
@@ -2442,7 +2356,7 @@
           <a:p>
             <a:fld id="{D0E3E56B-C3C4-8E4F-B314-D5C81CC34EEF}" type="slidenum">
               <a:rPr lang="en-US" smtClean="0"/>
-              <a:t>32</a:t>
+              <a:t>31</a:t>
             </a:fld>
             <a:endParaRPr lang="en-US"/>
           </a:p>
@@ -14142,587 +14056,6 @@
   <p:cSld>
     <p:spTree>
       <p:nvGrpSpPr>
-        <p:cNvPr id="1" name=""/>
-        <p:cNvGrpSpPr/>
-        <p:nvPr/>
-      </p:nvGrpSpPr>
-      <p:grpSpPr>
-        <a:xfrm>
-          <a:off x="0" y="0"/>
-          <a:ext cx="0" cy="0"/>
-          <a:chOff x="0" y="0"/>
-          <a:chExt cx="0" cy="0"/>
-        </a:xfrm>
-      </p:grpSpPr>
-      <p:sp>
-        <p:nvSpPr>
-          <p:cNvPr id="2" name="Shape 0"/>
-          <p:cNvSpPr/>
-          <p:nvPr/>
-        </p:nvSpPr>
-        <p:spPr>
-          <a:xfrm>
-            <a:off x="11686032" y="0"/>
-            <a:ext cx="505663" cy="6858000"/>
-          </a:xfrm>
-          <a:prstGeom prst="rect">
-            <a:avLst/>
-          </a:prstGeom>
-          <a:solidFill>
-            <a:srgbClr val="1F4899"/>
-          </a:solidFill>
-          <a:ln/>
-        </p:spPr>
-        <p:txBody>
-          <a:bodyPr/>
-          <a:lstStyle/>
-          <a:p>
-            <a:endParaRPr lang="en-US"/>
-          </a:p>
-        </p:txBody>
-      </p:sp>
-      <p:sp>
-        <p:nvSpPr>
-          <p:cNvPr id="3" name="Text 1"/>
-          <p:cNvSpPr/>
-          <p:nvPr/>
-        </p:nvSpPr>
-        <p:spPr>
-          <a:xfrm>
-            <a:off x="502920" y="274320"/>
-            <a:ext cx="10881360" cy="777240"/>
-          </a:xfrm>
-          <a:prstGeom prst="rect">
-            <a:avLst/>
-          </a:prstGeom>
-          <a:noFill/>
-          <a:ln/>
-        </p:spPr>
-        <p:txBody>
-          <a:bodyPr wrap="square" lIns="0" tIns="0" rIns="0" bIns="0" rtlCol="0" anchor="ctr"/>
-          <a:lstStyle/>
-          <a:p>
-            <a:pPr marL="0" indent="0" algn="l">
-              <a:buNone/>
-            </a:pPr>
-            <a:r>
-              <a:rPr lang="en-US" sz="2700" b="1" dirty="0">
-                <a:solidFill>
-                  <a:srgbClr val="1F4899"/>
-                </a:solidFill>
-                <a:latin typeface="Calibri" pitchFamily="34" charset="0"/>
-                <a:ea typeface="Calibri" pitchFamily="34" charset="-122"/>
-                <a:cs typeface="Calibri" pitchFamily="34" charset="-120"/>
-              </a:rPr>
-              <a:t>Concept Quiz 4</a:t>
-            </a:r>
-            <a:endParaRPr lang="en-US" sz="2700" dirty="0"/>
-          </a:p>
-        </p:txBody>
-      </p:sp>
-      <p:sp>
-        <p:nvSpPr>
-          <p:cNvPr id="4" name="Text 2"/>
-          <p:cNvSpPr/>
-          <p:nvPr/>
-        </p:nvSpPr>
-        <p:spPr>
-          <a:xfrm>
-            <a:off x="502920" y="18288"/>
-            <a:ext cx="10881360" cy="256032"/>
-          </a:xfrm>
-          <a:prstGeom prst="rect">
-            <a:avLst/>
-          </a:prstGeom>
-          <a:noFill/>
-          <a:ln/>
-        </p:spPr>
-        <p:txBody>
-          <a:bodyPr wrap="square" lIns="0" tIns="0" rIns="0" bIns="0" rtlCol="0" anchor="ctr"/>
-          <a:lstStyle/>
-          <a:p>
-            <a:pPr marL="0" indent="0" algn="l">
-              <a:buNone/>
-            </a:pPr>
-            <a:r>
-              <a:rPr lang="en-US" sz="1100" b="1" kern="0" spc="100" dirty="0">
-                <a:solidFill>
-                  <a:srgbClr val="6B7280"/>
-                </a:solidFill>
-                <a:latin typeface="Calibri" pitchFamily="34" charset="0"/>
-                <a:ea typeface="Calibri" pitchFamily="34" charset="-122"/>
-                <a:cs typeface="Calibri" pitchFamily="34" charset="-120"/>
-              </a:rPr>
-              <a:t>TOPIC 4</a:t>
-            </a:r>
-            <a:endParaRPr lang="en-US" sz="1100" dirty="0"/>
-          </a:p>
-        </p:txBody>
-      </p:sp>
-      <p:sp>
-        <p:nvSpPr>
-          <p:cNvPr id="5" name="Text 3"/>
-          <p:cNvSpPr/>
-          <p:nvPr/>
-        </p:nvSpPr>
-        <p:spPr>
-          <a:xfrm>
-            <a:off x="11686032" y="6446520"/>
-            <a:ext cx="505663" cy="320040"/>
-          </a:xfrm>
-          <a:prstGeom prst="rect">
-            <a:avLst/>
-          </a:prstGeom>
-          <a:noFill/>
-          <a:ln/>
-        </p:spPr>
-        <p:txBody>
-          <a:bodyPr wrap="square" lIns="0" tIns="0" rIns="0" bIns="0" rtlCol="0" anchor="ctr"/>
-          <a:lstStyle/>
-          <a:p>
-            <a:pPr marL="0" indent="0" algn="ctr">
-              <a:buNone/>
-            </a:pPr>
-            <a:r>
-              <a:rPr lang="en-US" sz="1100" dirty="0">
-                <a:solidFill>
-                  <a:srgbClr val="FFFFFF"/>
-                </a:solidFill>
-                <a:latin typeface="Calibri" pitchFamily="34" charset="0"/>
-                <a:ea typeface="Calibri" pitchFamily="34" charset="-122"/>
-                <a:cs typeface="Calibri" pitchFamily="34" charset="-120"/>
-              </a:rPr>
-              <a:t>21</a:t>
-            </a:r>
-            <a:endParaRPr lang="en-US" sz="1100" dirty="0"/>
-          </a:p>
-        </p:txBody>
-      </p:sp>
-      <p:sp>
-        <p:nvSpPr>
-          <p:cNvPr id="6" name="Shape 4"/>
-          <p:cNvSpPr/>
-          <p:nvPr/>
-        </p:nvSpPr>
-        <p:spPr>
-          <a:xfrm>
-            <a:off x="502920" y="1097280"/>
-            <a:ext cx="1965960" cy="329184"/>
-          </a:xfrm>
-          <a:prstGeom prst="roundRect">
-            <a:avLst>
-              <a:gd name="adj" fmla="val 50000"/>
-            </a:avLst>
-          </a:prstGeom>
-          <a:solidFill>
-            <a:srgbClr val="1F4899"/>
-          </a:solidFill>
-          <a:ln/>
-        </p:spPr>
-        <p:txBody>
-          <a:bodyPr/>
-          <a:lstStyle/>
-          <a:p>
-            <a:endParaRPr lang="en-US"/>
-          </a:p>
-        </p:txBody>
-      </p:sp>
-      <p:sp>
-        <p:nvSpPr>
-          <p:cNvPr id="7" name="Text 5"/>
-          <p:cNvSpPr/>
-          <p:nvPr/>
-        </p:nvSpPr>
-        <p:spPr>
-          <a:xfrm>
-            <a:off x="502920" y="1097280"/>
-            <a:ext cx="1965960" cy="329184"/>
-          </a:xfrm>
-          <a:prstGeom prst="rect">
-            <a:avLst/>
-          </a:prstGeom>
-          <a:noFill/>
-          <a:ln/>
-        </p:spPr>
-        <p:txBody>
-          <a:bodyPr wrap="square" lIns="0" tIns="0" rIns="0" bIns="0" rtlCol="0" anchor="ctr"/>
-          <a:lstStyle/>
-          <a:p>
-            <a:pPr marL="0" indent="0" algn="ctr">
-              <a:buNone/>
-            </a:pPr>
-            <a:r>
-              <a:rPr lang="en-US" sz="1100" b="1" dirty="0">
-                <a:solidFill>
-                  <a:srgbClr val="FFFFFF"/>
-                </a:solidFill>
-                <a:latin typeface="Calibri" pitchFamily="34" charset="0"/>
-                <a:ea typeface="Calibri" pitchFamily="34" charset="-122"/>
-                <a:cs typeface="Calibri" pitchFamily="34" charset="-120"/>
-              </a:rPr>
-              <a:t>CONCEPT QUIZ</a:t>
-            </a:r>
-            <a:endParaRPr lang="en-US" sz="1100" dirty="0"/>
-          </a:p>
-        </p:txBody>
-      </p:sp>
-      <p:sp>
-        <p:nvSpPr>
-          <p:cNvPr id="8" name="Shape 6"/>
-          <p:cNvSpPr/>
-          <p:nvPr/>
-        </p:nvSpPr>
-        <p:spPr>
-          <a:xfrm>
-            <a:off x="502920" y="1600200"/>
-            <a:ext cx="10972800" cy="1463040"/>
-          </a:xfrm>
-          <a:prstGeom prst="roundRect">
-            <a:avLst>
-              <a:gd name="adj" fmla="val 3125"/>
-            </a:avLst>
-          </a:prstGeom>
-          <a:solidFill>
-            <a:srgbClr val="FEF2F2"/>
-          </a:solidFill>
-          <a:ln w="15875">
-            <a:solidFill>
-              <a:srgbClr val="EF4444"/>
-            </a:solidFill>
-            <a:prstDash val="solid"/>
-          </a:ln>
-        </p:spPr>
-        <p:txBody>
-          <a:bodyPr/>
-          <a:lstStyle/>
-          <a:p>
-            <a:endParaRPr lang="en-US"/>
-          </a:p>
-        </p:txBody>
-      </p:sp>
-      <p:sp>
-        <p:nvSpPr>
-          <p:cNvPr id="9" name="Text 7"/>
-          <p:cNvSpPr/>
-          <p:nvPr/>
-        </p:nvSpPr>
-        <p:spPr>
-          <a:xfrm>
-            <a:off x="630936" y="1691640"/>
-            <a:ext cx="10716768" cy="274320"/>
-          </a:xfrm>
-          <a:prstGeom prst="rect">
-            <a:avLst/>
-          </a:prstGeom>
-          <a:noFill/>
-          <a:ln/>
-        </p:spPr>
-        <p:txBody>
-          <a:bodyPr wrap="square" lIns="0" tIns="0" rIns="0" bIns="0" rtlCol="0" anchor="ctr"/>
-          <a:lstStyle/>
-          <a:p>
-            <a:pPr marL="0" indent="0" algn="l">
-              <a:buNone/>
-            </a:pPr>
-            <a:r>
-              <a:rPr lang="en-US" sz="1300" b="1" dirty="0">
-                <a:solidFill>
-                  <a:srgbClr val="991B1B"/>
-                </a:solidFill>
-                <a:latin typeface="Calibri" pitchFamily="34" charset="0"/>
-                <a:ea typeface="Calibri" pitchFamily="34" charset="-122"/>
-                <a:cs typeface="Calibri" pitchFamily="34" charset="-120"/>
-              </a:rPr>
-              <a:t>Q1</a:t>
-            </a:r>
-            <a:endParaRPr lang="en-US" sz="1300" dirty="0"/>
-          </a:p>
-        </p:txBody>
-      </p:sp>
-      <p:sp>
-        <p:nvSpPr>
-          <p:cNvPr id="10" name="Text 8"/>
-          <p:cNvSpPr/>
-          <p:nvPr/>
-        </p:nvSpPr>
-        <p:spPr>
-          <a:xfrm>
-            <a:off x="649224" y="2020824"/>
-            <a:ext cx="10680192" cy="932688"/>
-          </a:xfrm>
-          <a:prstGeom prst="rect">
-            <a:avLst/>
-          </a:prstGeom>
-          <a:noFill/>
-          <a:ln/>
-        </p:spPr>
-        <p:txBody>
-          <a:bodyPr wrap="square" lIns="0" tIns="0" rIns="0" bIns="0" rtlCol="0" anchor="t"/>
-          <a:lstStyle/>
-          <a:p>
-            <a:pPr marL="0" indent="0" algn="l">
-              <a:lnSpc>
-                <a:spcPct val="102000"/>
-              </a:lnSpc>
-              <a:buNone/>
-            </a:pPr>
-            <a:r>
-              <a:rPr lang="en-US" sz="1300" b="1" dirty="0">
-                <a:solidFill>
-                  <a:srgbClr val="374151"/>
-                </a:solidFill>
-                <a:latin typeface="Calibri" pitchFamily="34" charset="0"/>
-                <a:ea typeface="Calibri" pitchFamily="34" charset="-122"/>
-                <a:cs typeface="Calibri" pitchFamily="34" charset="-120"/>
-              </a:rPr>
-              <a:t>A stock has β = 1.2. If the risk-free rate is 4.5% and the ERP is 5%, its cost of equity (CAPM) is:</a:t>
-            </a:r>
-            <a:endParaRPr lang="en-US" sz="1300" dirty="0"/>
-          </a:p>
-          <a:p>
-            <a:pPr marL="0" indent="0" algn="l">
-              <a:lnSpc>
-                <a:spcPct val="102000"/>
-              </a:lnSpc>
-              <a:spcBef>
-                <a:spcPts val="400"/>
-              </a:spcBef>
-              <a:buNone/>
-            </a:pPr>
-            <a:r>
-              <a:rPr lang="en-US" sz="1300" dirty="0">
-                <a:solidFill>
-                  <a:srgbClr val="991B1B"/>
-                </a:solidFill>
-                <a:latin typeface="Calibri" pitchFamily="34" charset="0"/>
-                <a:ea typeface="Calibri" pitchFamily="34" charset="-122"/>
-                <a:cs typeface="Calibri" pitchFamily="34" charset="-120"/>
-              </a:rPr>
-              <a:t>a) 9.0%     b) 9.5%     c) 10.5%     d) 6.0%</a:t>
-            </a:r>
-            <a:endParaRPr lang="en-US" sz="1300" dirty="0"/>
-          </a:p>
-        </p:txBody>
-      </p:sp>
-      <p:sp>
-        <p:nvSpPr>
-          <p:cNvPr id="11" name="Shape 9"/>
-          <p:cNvSpPr/>
-          <p:nvPr/>
-        </p:nvSpPr>
-        <p:spPr>
-          <a:xfrm>
-            <a:off x="502920" y="3154680"/>
-            <a:ext cx="10972800" cy="1600200"/>
-          </a:xfrm>
-          <a:prstGeom prst="roundRect">
-            <a:avLst>
-              <a:gd name="adj" fmla="val 2857"/>
-            </a:avLst>
-          </a:prstGeom>
-          <a:solidFill>
-            <a:srgbClr val="FEF3C7"/>
-          </a:solidFill>
-          <a:ln w="15875">
-            <a:solidFill>
-              <a:srgbClr val="F59E0B"/>
-            </a:solidFill>
-            <a:prstDash val="solid"/>
-          </a:ln>
-        </p:spPr>
-        <p:txBody>
-          <a:bodyPr/>
-          <a:lstStyle/>
-          <a:p>
-            <a:endParaRPr lang="en-US"/>
-          </a:p>
-        </p:txBody>
-      </p:sp>
-      <p:sp>
-        <p:nvSpPr>
-          <p:cNvPr id="12" name="Text 10"/>
-          <p:cNvSpPr/>
-          <p:nvPr/>
-        </p:nvSpPr>
-        <p:spPr>
-          <a:xfrm>
-            <a:off x="630936" y="3246120"/>
-            <a:ext cx="10716768" cy="274320"/>
-          </a:xfrm>
-          <a:prstGeom prst="rect">
-            <a:avLst/>
-          </a:prstGeom>
-          <a:noFill/>
-          <a:ln/>
-        </p:spPr>
-        <p:txBody>
-          <a:bodyPr wrap="square" lIns="0" tIns="0" rIns="0" bIns="0" rtlCol="0" anchor="ctr"/>
-          <a:lstStyle/>
-          <a:p>
-            <a:pPr marL="0" indent="0" algn="l">
-              <a:buNone/>
-            </a:pPr>
-            <a:r>
-              <a:rPr lang="en-US" sz="1300" b="1" dirty="0">
-                <a:solidFill>
-                  <a:srgbClr val="92400E"/>
-                </a:solidFill>
-                <a:latin typeface="Calibri" pitchFamily="34" charset="0"/>
-                <a:ea typeface="Calibri" pitchFamily="34" charset="-122"/>
-                <a:cs typeface="Calibri" pitchFamily="34" charset="-120"/>
-              </a:rPr>
-              <a:t>Q2</a:t>
-            </a:r>
-            <a:endParaRPr lang="en-US" sz="1300" dirty="0"/>
-          </a:p>
-        </p:txBody>
-      </p:sp>
-      <p:sp>
-        <p:nvSpPr>
-          <p:cNvPr id="13" name="Text 11"/>
-          <p:cNvSpPr/>
-          <p:nvPr/>
-        </p:nvSpPr>
-        <p:spPr>
-          <a:xfrm>
-            <a:off x="649224" y="3575304"/>
-            <a:ext cx="10680192" cy="1069848"/>
-          </a:xfrm>
-          <a:prstGeom prst="rect">
-            <a:avLst/>
-          </a:prstGeom>
-          <a:noFill/>
-          <a:ln/>
-        </p:spPr>
-        <p:txBody>
-          <a:bodyPr wrap="square" lIns="0" tIns="0" rIns="0" bIns="0" rtlCol="0" anchor="t"/>
-          <a:lstStyle/>
-          <a:p>
-            <a:pPr marL="0" indent="0" algn="l">
-              <a:lnSpc>
-                <a:spcPct val="102000"/>
-              </a:lnSpc>
-              <a:buNone/>
-            </a:pPr>
-            <a:r>
-              <a:rPr lang="en-US" sz="1300" b="1" dirty="0">
-                <a:solidFill>
-                  <a:srgbClr val="374151"/>
-                </a:solidFill>
-                <a:latin typeface="Calibri" pitchFamily="34" charset="0"/>
-                <a:ea typeface="Calibri" pitchFamily="34" charset="-122"/>
-                <a:cs typeface="Calibri" pitchFamily="34" charset="-120"/>
-              </a:rPr>
-              <a:t>When discounting free cash flow to equity (FCFE), the appropriate rate is:</a:t>
-            </a:r>
-            <a:endParaRPr lang="en-US" sz="1300" dirty="0"/>
-          </a:p>
-          <a:p>
-            <a:pPr marL="0" indent="0" algn="l">
-              <a:lnSpc>
-                <a:spcPct val="102000"/>
-              </a:lnSpc>
-              <a:spcBef>
-                <a:spcPts val="400"/>
-              </a:spcBef>
-              <a:buNone/>
-            </a:pPr>
-            <a:r>
-              <a:rPr lang="en-US" sz="1300" dirty="0">
-                <a:solidFill>
-                  <a:srgbClr val="92400E"/>
-                </a:solidFill>
-                <a:latin typeface="Calibri" pitchFamily="34" charset="0"/>
-                <a:ea typeface="Calibri" pitchFamily="34" charset="-122"/>
-                <a:cs typeface="Calibri" pitchFamily="34" charset="-120"/>
-              </a:rPr>
-              <a:t>a) the cost of equity     b) the WACC     c) the risk-free rate     d) the cost of debt</a:t>
-            </a:r>
-            <a:endParaRPr lang="en-US" sz="1300" dirty="0"/>
-          </a:p>
-        </p:txBody>
-      </p:sp>
-      <p:sp>
-        <p:nvSpPr>
-          <p:cNvPr id="14" name="Shape 12"/>
-          <p:cNvSpPr/>
-          <p:nvPr/>
-        </p:nvSpPr>
-        <p:spPr>
-          <a:xfrm>
-            <a:off x="502920" y="5074920"/>
-            <a:ext cx="10972800" cy="548640"/>
-          </a:xfrm>
-          <a:prstGeom prst="roundRect">
-            <a:avLst>
-              <a:gd name="adj" fmla="val 8333"/>
-            </a:avLst>
-          </a:prstGeom>
-          <a:solidFill>
-            <a:srgbClr val="1F4899"/>
-          </a:solidFill>
-          <a:ln/>
-        </p:spPr>
-        <p:txBody>
-          <a:bodyPr/>
-          <a:lstStyle/>
-          <a:p>
-            <a:endParaRPr lang="en-US"/>
-          </a:p>
-        </p:txBody>
-      </p:sp>
-      <p:sp>
-        <p:nvSpPr>
-          <p:cNvPr id="15" name="Text 13"/>
-          <p:cNvSpPr/>
-          <p:nvPr/>
-        </p:nvSpPr>
-        <p:spPr>
-          <a:xfrm>
-            <a:off x="502920" y="5074920"/>
-            <a:ext cx="10972800" cy="548640"/>
-          </a:xfrm>
-          <a:prstGeom prst="rect">
-            <a:avLst/>
-          </a:prstGeom>
-          <a:noFill/>
-          <a:ln/>
-        </p:spPr>
-        <p:txBody>
-          <a:bodyPr wrap="square" rtlCol="0" anchor="ctr"/>
-          <a:lstStyle/>
-          <a:p>
-            <a:pPr marL="0" indent="0" algn="ctr">
-              <a:buNone/>
-            </a:pPr>
-            <a:r>
-              <a:rPr lang="en-US" sz="1400" b="1" dirty="0">
-                <a:solidFill>
-                  <a:srgbClr val="FFFFFF"/>
-                </a:solidFill>
-                <a:latin typeface="Calibri" pitchFamily="34" charset="0"/>
-                <a:ea typeface="Calibri" pitchFamily="34" charset="-122"/>
-                <a:cs typeface="Calibri" pitchFamily="34" charset="-120"/>
-              </a:rPr>
-              <a:t>Answers:  1 → c  (4.5% + 1.2 × 5% = 10.5%)     2 → a</a:t>
-            </a:r>
-            <a:endParaRPr lang="en-US" sz="1400" dirty="0"/>
-          </a:p>
-        </p:txBody>
-      </p:sp>
-    </p:spTree>
-  </p:cSld>
-  <p:clrMapOvr>
-    <a:masterClrMapping/>
-  </p:clrMapOvr>
-</p:sld>
-</file>
-
-<file path=ppt/slides/slide25.xml><?xml version="1.0" encoding="utf-8"?>
-<p:sld xmlns:a="http://schemas.openxmlformats.org/drawingml/2006/main" xmlns:r="http://schemas.openxmlformats.org/officeDocument/2006/relationships" xmlns:p="http://schemas.openxmlformats.org/presentationml/2006/main">
-  <p:cSld>
-    <p:spTree>
-      <p:nvGrpSpPr>
         <p:cNvPr id="1" name="">
           <a:extLst>
             <a:ext uri="{FF2B5EF4-FFF2-40B4-BE49-F238E27FC236}">
@@ -14784,7 +14117,7 @@
 </p:sld>
 </file>
 
-<file path=ppt/slides/slide26.xml><?xml version="1.0" encoding="utf-8"?>
+<file path=ppt/slides/slide25.xml><?xml version="1.0" encoding="utf-8"?>
 <p:sld xmlns:a="http://schemas.openxmlformats.org/drawingml/2006/main" xmlns:r="http://schemas.openxmlformats.org/officeDocument/2006/relationships" xmlns:p="http://schemas.openxmlformats.org/presentationml/2006/main">
   <p:cSld>
     <p:spTree>
@@ -16658,7 +15991,7 @@
 </p:sld>
 </file>
 
-<file path=ppt/slides/slide27.xml><?xml version="1.0" encoding="utf-8"?>
+<file path=ppt/slides/slide26.xml><?xml version="1.0" encoding="utf-8"?>
 <p:sld xmlns:a="http://schemas.openxmlformats.org/drawingml/2006/main" xmlns:r="http://schemas.openxmlformats.org/officeDocument/2006/relationships" xmlns:p="http://schemas.openxmlformats.org/presentationml/2006/main">
   <p:cSld>
     <p:spTree>
@@ -17573,7 +16906,7 @@
 </p:sld>
 </file>
 
-<file path=ppt/slides/slide28.xml><?xml version="1.0" encoding="utf-8"?>
+<file path=ppt/slides/slide27.xml><?xml version="1.0" encoding="utf-8"?>
 <p:sld xmlns:a="http://schemas.openxmlformats.org/drawingml/2006/main" xmlns:r="http://schemas.openxmlformats.org/officeDocument/2006/relationships" xmlns:p="http://schemas.openxmlformats.org/presentationml/2006/main">
   <p:cSld>
     <p:spTree>
@@ -18619,7 +17952,7 @@
 </p:sld>
 </file>
 
-<file path=ppt/slides/slide29.xml><?xml version="1.0" encoding="utf-8"?>
+<file path=ppt/slides/slide28.xml><?xml version="1.0" encoding="utf-8"?>
 <p:sld xmlns:a="http://schemas.openxmlformats.org/drawingml/2006/main" xmlns:r="http://schemas.openxmlformats.org/officeDocument/2006/relationships" xmlns:p="http://schemas.openxmlformats.org/presentationml/2006/main">
   <p:cSld>
     <p:spTree>
@@ -19814,73 +19147,7 @@
 </p:sld>
 </file>
 
-<file path=ppt/slides/slide3.xml><?xml version="1.0" encoding="utf-8"?>
-<p:sld xmlns:a="http://schemas.openxmlformats.org/drawingml/2006/main" xmlns:r="http://schemas.openxmlformats.org/officeDocument/2006/relationships" xmlns:p="http://schemas.openxmlformats.org/presentationml/2006/main">
-  <p:cSld>
-    <p:spTree>
-      <p:nvGrpSpPr>
-        <p:cNvPr id="1" name="">
-          <a:extLst>
-            <a:ext uri="{FF2B5EF4-FFF2-40B4-BE49-F238E27FC236}">
-              <a16:creationId xmlns:a16="http://schemas.microsoft.com/office/drawing/2014/main" id="{40B431E1-DCCD-AECB-5CC6-A6A28CC98607}"/>
-            </a:ext>
-          </a:extLst>
-        </p:cNvPr>
-        <p:cNvGrpSpPr/>
-        <p:nvPr/>
-      </p:nvGrpSpPr>
-      <p:grpSpPr>
-        <a:xfrm>
-          <a:off x="0" y="0"/>
-          <a:ext cx="0" cy="0"/>
-          <a:chOff x="0" y="0"/>
-          <a:chExt cx="0" cy="0"/>
-        </a:xfrm>
-      </p:grpSpPr>
-      <p:sp>
-        <p:nvSpPr>
-          <p:cNvPr id="2" name="Title 1">
-            <a:extLst>
-              <a:ext uri="{FF2B5EF4-FFF2-40B4-BE49-F238E27FC236}">
-                <a16:creationId xmlns:a16="http://schemas.microsoft.com/office/drawing/2014/main" id="{A9A70150-E3CD-D6F5-4134-EB4ADB857847}"/>
-              </a:ext>
-            </a:extLst>
-          </p:cNvPr>
-          <p:cNvSpPr>
-            <a:spLocks noGrp="1"/>
-          </p:cNvSpPr>
-          <p:nvPr>
-            <p:ph type="title"/>
-          </p:nvPr>
-        </p:nvSpPr>
-        <p:spPr/>
-        <p:txBody>
-          <a:bodyPr/>
-          <a:lstStyle/>
-          <a:p>
-            <a:r>
-              <a:rPr lang="en-US" dirty="0">
-                <a:latin typeface="+mn-lt"/>
-              </a:rPr>
-              <a:t>1. The Time Value of Money</a:t>
-            </a:r>
-          </a:p>
-        </p:txBody>
-      </p:sp>
-    </p:spTree>
-    <p:extLst>
-      <p:ext uri="{BB962C8B-B14F-4D97-AF65-F5344CB8AC3E}">
-        <p14:creationId xmlns:p14="http://schemas.microsoft.com/office/powerpoint/2010/main" val="4098012946"/>
-      </p:ext>
-    </p:extLst>
-  </p:cSld>
-  <p:clrMapOvr>
-    <a:masterClrMapping/>
-  </p:clrMapOvr>
-</p:sld>
-</file>
-
-<file path=ppt/slides/slide30.xml><?xml version="1.0" encoding="utf-8"?>
+<file path=ppt/slides/slide29.xml><?xml version="1.0" encoding="utf-8"?>
 <p:sld xmlns:a="http://schemas.openxmlformats.org/drawingml/2006/main" xmlns:r="http://schemas.openxmlformats.org/officeDocument/2006/relationships" xmlns:p="http://schemas.openxmlformats.org/presentationml/2006/main">
   <p:cSld>
     <p:spTree>
@@ -20844,7 +20111,73 @@
 </p:sld>
 </file>
 
-<file path=ppt/slides/slide31.xml><?xml version="1.0" encoding="utf-8"?>
+<file path=ppt/slides/slide3.xml><?xml version="1.0" encoding="utf-8"?>
+<p:sld xmlns:a="http://schemas.openxmlformats.org/drawingml/2006/main" xmlns:r="http://schemas.openxmlformats.org/officeDocument/2006/relationships" xmlns:p="http://schemas.openxmlformats.org/presentationml/2006/main">
+  <p:cSld>
+    <p:spTree>
+      <p:nvGrpSpPr>
+        <p:cNvPr id="1" name="">
+          <a:extLst>
+            <a:ext uri="{FF2B5EF4-FFF2-40B4-BE49-F238E27FC236}">
+              <a16:creationId xmlns:a16="http://schemas.microsoft.com/office/drawing/2014/main" id="{40B431E1-DCCD-AECB-5CC6-A6A28CC98607}"/>
+            </a:ext>
+          </a:extLst>
+        </p:cNvPr>
+        <p:cNvGrpSpPr/>
+        <p:nvPr/>
+      </p:nvGrpSpPr>
+      <p:grpSpPr>
+        <a:xfrm>
+          <a:off x="0" y="0"/>
+          <a:ext cx="0" cy="0"/>
+          <a:chOff x="0" y="0"/>
+          <a:chExt cx="0" cy="0"/>
+        </a:xfrm>
+      </p:grpSpPr>
+      <p:sp>
+        <p:nvSpPr>
+          <p:cNvPr id="2" name="Title 1">
+            <a:extLst>
+              <a:ext uri="{FF2B5EF4-FFF2-40B4-BE49-F238E27FC236}">
+                <a16:creationId xmlns:a16="http://schemas.microsoft.com/office/drawing/2014/main" id="{A9A70150-E3CD-D6F5-4134-EB4ADB857847}"/>
+              </a:ext>
+            </a:extLst>
+          </p:cNvPr>
+          <p:cNvSpPr>
+            <a:spLocks noGrp="1"/>
+          </p:cNvSpPr>
+          <p:nvPr>
+            <p:ph type="title"/>
+          </p:nvPr>
+        </p:nvSpPr>
+        <p:spPr/>
+        <p:txBody>
+          <a:bodyPr/>
+          <a:lstStyle/>
+          <a:p>
+            <a:r>
+              <a:rPr lang="en-US" dirty="0">
+                <a:latin typeface="+mn-lt"/>
+              </a:rPr>
+              <a:t>1. The Time Value of Money</a:t>
+            </a:r>
+          </a:p>
+        </p:txBody>
+      </p:sp>
+    </p:spTree>
+    <p:extLst>
+      <p:ext uri="{BB962C8B-B14F-4D97-AF65-F5344CB8AC3E}">
+        <p14:creationId xmlns:p14="http://schemas.microsoft.com/office/powerpoint/2010/main" val="4098012946"/>
+      </p:ext>
+    </p:extLst>
+  </p:cSld>
+  <p:clrMapOvr>
+    <a:masterClrMapping/>
+  </p:clrMapOvr>
+</p:sld>
+</file>
+
+<file path=ppt/slides/slide30.xml><?xml version="1.0" encoding="utf-8"?>
 <p:sld xmlns:a="http://schemas.openxmlformats.org/drawingml/2006/main" xmlns:r="http://schemas.openxmlformats.org/officeDocument/2006/relationships" xmlns:p="http://schemas.openxmlformats.org/presentationml/2006/main">
   <p:cSld>
     <p:spTree>
@@ -20912,7 +20245,7 @@
 </p:sld>
 </file>
 
-<file path=ppt/slides/slide32.xml><?xml version="1.0" encoding="utf-8"?>
+<file path=ppt/slides/slide31.xml><?xml version="1.0" encoding="utf-8"?>
 <p:sld xmlns:a="http://schemas.openxmlformats.org/drawingml/2006/main" xmlns:r="http://schemas.openxmlformats.org/officeDocument/2006/relationships" xmlns:p="http://schemas.openxmlformats.org/presentationml/2006/main">
   <p:cSld>
     <p:spTree>
@@ -21147,13 +20480,13 @@
   <p:clrMapOvr>
     <a:masterClrMapping/>
   </p:clrMapOvr>
-  <mc:AlternateContent xmlns:mc="http://schemas.openxmlformats.org/markup-compatibility/2006">
-    <mc:Choice xmlns:p14="http://schemas.microsoft.com/office/powerpoint/2010/main" Requires="p14">
+  <mc:AlternateContent xmlns:mc="http://schemas.openxmlformats.org/markup-compatibility/2006" xmlns:p14="http://schemas.microsoft.com/office/powerpoint/2010/main">
+    <mc:Choice Requires="p14">
       <p:transition spd="slow" p14:dur="800">
         <p:circle/>
       </p:transition>
     </mc:Choice>
-    <mc:Fallback>
+    <mc:Fallback xmlns="">
       <p:transition spd="slow">
         <p:circle/>
       </p:transition>

</xml_diff>